<commit_message>
Slides: sd-09-020 to the style's type scale, re-export PPTX
Co-Authored-By: Claude Opus 5.5 <noreply@anthropic.com>
Claude-Session: https://claude.ai/code/session_014EdyZwPF7XnU2uvEPKZ7Pf
</commit_message>
<xml_diff>
--- a/system-design-101/vi/lessons/sd-09-020/slides/sd-09-020.pptx
+++ b/system-design-101/vi/lessons/sd-09-020/slides/sd-09-020.pptx
@@ -1806,7 +1806,7 @@
               <a:buNone/>
             </a:pPr>
             <a:r>
-              <a:rPr lang="en-US" sz="7500" dirty="0" spc="-64" kern="0">
+              <a:rPr lang="en-US" sz="8100" dirty="0" spc="-63" kern="0">
                 <a:solidFill>
                   <a:srgbClr val="F3EEE3"/>
                 </a:solidFill>
@@ -1817,7 +1817,7 @@
               <a:t>Từ</a:t>
             </a:r>
             <a:r>
-              <a:rPr lang="en-US" sz="7500" dirty="0" spc="2" kern="0">
+              <a:rPr lang="en-US" sz="8100" dirty="0" spc="3" kern="0">
                 <a:solidFill>
                   <a:srgbClr val="F3EEE3"/>
                 </a:solidFill>
@@ -1828,7 +1828,7 @@
               <a:t> thay</a:t>
             </a:r>
             <a:r>
-              <a:rPr lang="en-US" sz="7500" dirty="0" spc="15" kern="0">
+              <a:rPr lang="en-US" sz="8100" dirty="0" spc="15" kern="0">
                 <a:solidFill>
                   <a:srgbClr val="F3EEE3"/>
                 </a:solidFill>
@@ -1839,7 +1839,7 @@
               <a:t> đổi</a:t>
             </a:r>
             <a:r>
-              <a:rPr lang="en-US" sz="7500" dirty="0" spc="1" kern="0">
+              <a:rPr lang="en-US" sz="8100" dirty="0" spc="1" kern="0">
                 <a:solidFill>
                   <a:srgbClr val="F3EEE3"/>
                 </a:solidFill>
@@ -1850,7 +1850,7 @@
               <a:t> code</a:t>
             </a:r>
             <a:r>
-              <a:rPr lang="en-US" sz="7500" dirty="0" spc="-69" kern="0">
+              <a:rPr lang="en-US" sz="8100" dirty="0" spc="-77" kern="0">
                 <a:solidFill>
                   <a:srgbClr val="F3EEE3"/>
                 </a:solidFill>
@@ -1861,7 +1861,7 @@
               <a:t> tới</a:t>
             </a:r>
             <a:r>
-              <a:rPr lang="en-US" sz="7500" dirty="0" spc="-5" kern="0">
+              <a:rPr lang="en-US" sz="8100" dirty="0" spc="-4" kern="0">
                 <a:solidFill>
                   <a:srgbClr val="F3EEE3"/>
                 </a:solidFill>
@@ -1872,7 +1872,7 @@
               <a:t> bản</a:t>
             </a:r>
             <a:r>
-              <a:rPr lang="en-US" sz="7500" dirty="0" spc="3" kern="0">
+              <a:rPr lang="en-US" sz="8100" dirty="0" spc="2" kern="0">
                 <a:solidFill>
                   <a:srgbClr val="F3EEE3"/>
                 </a:solidFill>
@@ -1883,7 +1883,7 @@
               <a:t> chạy</a:t>
             </a:r>
             <a:r>
-              <a:rPr lang="en-US" sz="7500" dirty="0" spc="-6" kern="0">
+              <a:rPr lang="en-US" sz="8100" dirty="0" spc="-6" kern="0">
                 <a:solidFill>
                   <a:srgbClr val="F3EEE3"/>
                 </a:solidFill>
@@ -1893,7 +1893,7 @@
               </a:rPr>
               <a:t> production</a:t>
             </a:r>
-            <a:endParaRPr lang="en-US" sz="7500" dirty="0"/>
+            <a:endParaRPr lang="en-US" sz="8100" dirty="0"/>
           </a:p>
         </p:txBody>
       </p:sp>
@@ -1905,7 +1905,7 @@
         </p:nvSpPr>
         <p:spPr>
           <a:xfrm>
-            <a:off x="914400" y="5715000"/>
+            <a:off x="914400" y="6096000"/>
             <a:ext cx="8572500" cy="1047750"/>
           </a:xfrm>
           <a:prstGeom prst="rect">
@@ -2943,7 +2943,7 @@
         <p:spPr>
           <a:xfrm>
             <a:off x="1238250" y="4048125"/>
-            <a:ext cx="4667250" cy="428625"/>
+            <a:ext cx="4667250" cy="476250"/>
           </a:xfrm>
           <a:prstGeom prst="rect">
             <a:avLst/>
@@ -2959,7 +2959,7 @@
               <a:buNone/>
             </a:pPr>
             <a:r>
-              <a:rPr lang="en-US" sz="2250" dirty="0" spc="0" kern="0">
+              <a:rPr lang="en-US" sz="2550" dirty="0" spc="2" kern="0">
                 <a:solidFill>
                   <a:srgbClr val="F3EEE3"/>
                 </a:solidFill>
@@ -2970,7 +2970,7 @@
               <a:t>tích</a:t>
             </a:r>
             <a:r>
-              <a:rPr lang="en-US" sz="2250" dirty="0" spc="3" kern="0">
+              <a:rPr lang="en-US" sz="2550" dirty="0" spc="-1" kern="0">
                 <a:solidFill>
                   <a:srgbClr val="F3EEE3"/>
                 </a:solidFill>
@@ -2981,7 +2981,7 @@
               <a:t> hợp</a:t>
             </a:r>
             <a:r>
-              <a:rPr lang="en-US" sz="2250" dirty="0" spc="-1" kern="0">
+              <a:rPr lang="en-US" sz="2550" dirty="0" spc="0" kern="0">
                 <a:solidFill>
                   <a:srgbClr val="F3EEE3"/>
                 </a:solidFill>
@@ -2989,20 +2989,9 @@
                 <a:ea typeface="Be Vietnam Pro" pitchFamily="34" charset="-122"/>
                 <a:cs typeface="Be Vietnam Pro" pitchFamily="34" charset="-120"/>
               </a:rPr>
-              <a:t> liên</a:t>
-            </a:r>
-            <a:r>
-              <a:rPr lang="en-US" sz="2250" dirty="0" spc="4" kern="0">
-                <a:solidFill>
-                  <a:srgbClr val="F3EEE3"/>
-                </a:solidFill>
-                <a:latin typeface="Be Vietnam Pro" pitchFamily="34" charset="0"/>
-                <a:ea typeface="Be Vietnam Pro" pitchFamily="34" charset="-122"/>
-                <a:cs typeface="Be Vietnam Pro" pitchFamily="34" charset="-120"/>
-              </a:rPr>
-              <a:t> tục</a:t>
-            </a:r>
-            <a:endParaRPr lang="en-US" sz="2250" dirty="0"/>
+              <a:t> liên tục</a:t>
+            </a:r>
+            <a:endParaRPr lang="en-US" sz="2550" dirty="0"/>
           </a:p>
         </p:txBody>
       </p:sp>
@@ -3115,7 +3104,7 @@
         <p:spPr>
           <a:xfrm>
             <a:off x="6819900" y="4048125"/>
-            <a:ext cx="4667250" cy="428625"/>
+            <a:ext cx="4667250" cy="476250"/>
           </a:xfrm>
           <a:prstGeom prst="rect">
             <a:avLst/>
@@ -3131,7 +3120,7 @@
               <a:buNone/>
             </a:pPr>
             <a:r>
-              <a:rPr lang="en-US" sz="2250" dirty="0" spc="-5" kern="0">
+              <a:rPr lang="en-US" sz="2550" dirty="0" spc="2" kern="0">
                 <a:solidFill>
                   <a:srgbClr val="F3EEE3"/>
                 </a:solidFill>
@@ -3142,7 +3131,7 @@
               <a:t>mã</a:t>
             </a:r>
             <a:r>
-              <a:rPr lang="en-US" sz="2250" dirty="0" spc="19" kern="0">
+              <a:rPr lang="en-US" sz="2550" dirty="0" spc="21" kern="0">
                 <a:solidFill>
                   <a:srgbClr val="F3EEE3"/>
                 </a:solidFill>
@@ -3153,7 +3142,7 @@
               <a:t> định</a:t>
             </a:r>
             <a:r>
-              <a:rPr lang="en-US" sz="2250" dirty="0" spc="1" kern="0">
+              <a:rPr lang="en-US" sz="2550" dirty="0" spc="-1" kern="0">
                 <a:solidFill>
                   <a:srgbClr val="F3EEE3"/>
                 </a:solidFill>
@@ -3163,7 +3152,7 @@
               </a:rPr>
               <a:t> danh</a:t>
             </a:r>
-            <a:endParaRPr lang="en-US" sz="2250" dirty="0"/>
+            <a:endParaRPr lang="en-US" sz="2550" dirty="0"/>
           </a:p>
         </p:txBody>
       </p:sp>
@@ -3287,7 +3276,7 @@
         <p:spPr>
           <a:xfrm>
             <a:off x="12401550" y="4048125"/>
-            <a:ext cx="4667250" cy="428625"/>
+            <a:ext cx="4667250" cy="476250"/>
           </a:xfrm>
           <a:prstGeom prst="rect">
             <a:avLst/>
@@ -3303,7 +3292,7 @@
               <a:buNone/>
             </a:pPr>
             <a:r>
-              <a:rPr lang="en-US" sz="2250" dirty="0" spc="13" kern="0">
+              <a:rPr lang="en-US" sz="2550" dirty="0" spc="19" kern="0">
                 <a:solidFill>
                   <a:srgbClr val="F3EEE3"/>
                 </a:solidFill>
@@ -3314,7 +3303,7 @@
               <a:t>đảm</a:t>
             </a:r>
             <a:r>
-              <a:rPr lang="en-US" sz="2250" dirty="0" spc="-4" kern="0">
+              <a:rPr lang="en-US" sz="2550" dirty="0" spc="-3" kern="0">
                 <a:solidFill>
                   <a:srgbClr val="F3EEE3"/>
                 </a:solidFill>
@@ -3325,7 +3314,7 @@
               <a:t> bảo</a:t>
             </a:r>
             <a:r>
-              <a:rPr lang="en-US" sz="2250" dirty="0" spc="-8" kern="0">
+              <a:rPr lang="en-US" sz="2550" dirty="0" spc="-9" kern="0">
                 <a:solidFill>
                   <a:srgbClr val="F3EEE3"/>
                 </a:solidFill>
@@ -3336,7 +3325,7 @@
               <a:t> chất</a:t>
             </a:r>
             <a:r>
-              <a:rPr lang="en-US" sz="2250" dirty="0" spc="6" kern="0">
+              <a:rPr lang="en-US" sz="2550" dirty="0" spc="5" kern="0">
                 <a:solidFill>
                   <a:srgbClr val="F3EEE3"/>
                 </a:solidFill>
@@ -3346,7 +3335,7 @@
               </a:rPr>
               <a:t> lượng</a:t>
             </a:r>
-            <a:endParaRPr lang="en-US" sz="2250" dirty="0"/>
+            <a:endParaRPr lang="en-US" sz="2550" dirty="0"/>
           </a:p>
         </p:txBody>
       </p:sp>
@@ -3481,7 +3470,7 @@
         <p:spPr>
           <a:xfrm>
             <a:off x="1238250" y="6238875"/>
-            <a:ext cx="7429500" cy="428625"/>
+            <a:ext cx="7429500" cy="476250"/>
           </a:xfrm>
           <a:prstGeom prst="rect">
             <a:avLst/>
@@ -3497,7 +3486,7 @@
               <a:buNone/>
             </a:pPr>
             <a:r>
-              <a:rPr lang="en-US" sz="2250" dirty="0" spc="-1" kern="0">
+              <a:rPr lang="en-US" sz="2550" dirty="0" spc="1" kern="0">
                 <a:solidFill>
                   <a:srgbClr val="F3EEE3"/>
                 </a:solidFill>
@@ -3508,7 +3497,7 @@
               <a:t>kỹ</a:t>
             </a:r>
             <a:r>
-              <a:rPr lang="en-US" sz="2250" dirty="0" spc="-8" kern="0">
+              <a:rPr lang="en-US" sz="2550" dirty="0" spc="-6" kern="0">
                 <a:solidFill>
                   <a:srgbClr val="F3EEE3"/>
                 </a:solidFill>
@@ -3519,7 +3508,7 @@
               <a:t> thuật</a:t>
             </a:r>
             <a:r>
-              <a:rPr lang="en-US" sz="2250" dirty="0" spc="19" kern="0">
+              <a:rPr lang="en-US" sz="2550" dirty="0" spc="17" kern="0">
                 <a:solidFill>
                   <a:srgbClr val="F3EEE3"/>
                 </a:solidFill>
@@ -3530,7 +3519,7 @@
               <a:t> độ</a:t>
             </a:r>
             <a:r>
-              <a:rPr lang="en-US" sz="2250" dirty="0" spc="0" kern="0">
+              <a:rPr lang="en-US" sz="2550" dirty="0" spc="0" kern="0">
                 <a:solidFill>
                   <a:srgbClr val="F3EEE3"/>
                 </a:solidFill>
@@ -3541,7 +3530,7 @@
               <a:t> tin</a:t>
             </a:r>
             <a:r>
-              <a:rPr lang="en-US" sz="2250" dirty="0" spc="-7" kern="0">
+              <a:rPr lang="en-US" sz="2550" dirty="0" spc="-10" kern="0">
                 <a:solidFill>
                   <a:srgbClr val="F3EEE3"/>
                 </a:solidFill>
@@ -3552,7 +3541,7 @@
               <a:t> cậy</a:t>
             </a:r>
             <a:r>
-              <a:rPr lang="en-US" sz="2250" dirty="0" spc="2" kern="0">
+              <a:rPr lang="en-US" sz="2550" dirty="0" spc="-1" kern="0">
                 <a:solidFill>
                   <a:srgbClr val="F3EEE3"/>
                 </a:solidFill>
@@ -3560,10 +3549,10 @@
                 <a:ea typeface="Be Vietnam Pro" pitchFamily="34" charset="-122"/>
                 <a:cs typeface="Be Vietnam Pro" pitchFamily="34" charset="-120"/>
               </a:rPr>
-              <a:t> của dịch</a:t>
-            </a:r>
-            <a:r>
-              <a:rPr lang="en-US" sz="2250" dirty="0" spc="1" kern="0">
+              <a:t> của</a:t>
+            </a:r>
+            <a:r>
+              <a:rPr lang="en-US" sz="2550" dirty="0" spc="0" kern="0">
                 <a:solidFill>
                   <a:srgbClr val="F3EEE3"/>
                 </a:solidFill>
@@ -3571,9 +3560,20 @@
                 <a:ea typeface="Be Vietnam Pro" pitchFamily="34" charset="-122"/>
                 <a:cs typeface="Be Vietnam Pro" pitchFamily="34" charset="-120"/>
               </a:rPr>
+              <a:t> dịch</a:t>
+            </a:r>
+            <a:r>
+              <a:rPr lang="en-US" sz="2550" dirty="0" spc="-3" kern="0">
+                <a:solidFill>
+                  <a:srgbClr val="F3EEE3"/>
+                </a:solidFill>
+                <a:latin typeface="Be Vietnam Pro" pitchFamily="34" charset="0"/>
+                <a:ea typeface="Be Vietnam Pro" pitchFamily="34" charset="-122"/>
+                <a:cs typeface="Be Vietnam Pro" pitchFamily="34" charset="-120"/>
+              </a:rPr>
               <a:t> vụ</a:t>
             </a:r>
-            <a:endParaRPr lang="en-US" sz="2250" dirty="0"/>
+            <a:endParaRPr lang="en-US" sz="2550" dirty="0"/>
           </a:p>
         </p:txBody>
       </p:sp>
@@ -3708,7 +3708,7 @@
         <p:spPr>
           <a:xfrm>
             <a:off x="9610725" y="6238875"/>
-            <a:ext cx="7429500" cy="428625"/>
+            <a:ext cx="7429500" cy="476250"/>
           </a:xfrm>
           <a:prstGeom prst="rect">
             <a:avLst/>
@@ -3724,7 +3724,7 @@
               <a:buNone/>
             </a:pPr>
             <a:r>
-              <a:rPr lang="en-US" sz="2250" dirty="0" spc="-4" kern="0">
+              <a:rPr lang="en-US" sz="2550" dirty="0" spc="2" kern="0">
                 <a:solidFill>
                   <a:srgbClr val="F3EEE3"/>
                 </a:solidFill>
@@ -3735,7 +3735,7 @@
               <a:t>kiểm</a:t>
             </a:r>
             <a:r>
-              <a:rPr lang="en-US" sz="2250" dirty="0" spc="3" kern="0">
+              <a:rPr lang="en-US" sz="2550" dirty="0" spc="-1" kern="0">
                 <a:solidFill>
                   <a:srgbClr val="F3EEE3"/>
                 </a:solidFill>
@@ -3746,7 +3746,7 @@
               <a:t> thử</a:t>
             </a:r>
             <a:r>
-              <a:rPr lang="en-US" sz="2250" dirty="0" spc="1" kern="0">
+              <a:rPr lang="en-US" sz="2550" dirty="0" spc="0" kern="0">
                 <a:solidFill>
                   <a:srgbClr val="F3EEE3"/>
                 </a:solidFill>
@@ -3754,10 +3754,10 @@
                 <a:ea typeface="Be Vietnam Pro" pitchFamily="34" charset="-122"/>
                 <a:cs typeface="Be Vietnam Pro" pitchFamily="34" charset="-120"/>
               </a:rPr>
-              <a:t> chấp</a:t>
-            </a:r>
-            <a:r>
-              <a:rPr lang="en-US" sz="2250" dirty="0" spc="0" kern="0">
+              <a:t> chấp nhận</a:t>
+            </a:r>
+            <a:r>
+              <a:rPr lang="en-US" sz="2550" dirty="0" spc="-2" kern="0">
                 <a:solidFill>
                   <a:srgbClr val="F3EEE3"/>
                 </a:solidFill>
@@ -3765,10 +3765,10 @@
                 <a:ea typeface="Be Vietnam Pro" pitchFamily="34" charset="-122"/>
                 <a:cs typeface="Be Vietnam Pro" pitchFamily="34" charset="-120"/>
               </a:rPr>
-              <a:t> nhận</a:t>
-            </a:r>
-            <a:r>
-              <a:rPr lang="en-US" sz="2250" dirty="0" spc="3" kern="0">
+              <a:t> của</a:t>
+            </a:r>
+            <a:r>
+              <a:rPr lang="en-US" sz="2550" dirty="0" spc="5" kern="0">
                 <a:solidFill>
                   <a:srgbClr val="F3EEE3"/>
                 </a:solidFill>
@@ -3776,10 +3776,10 @@
                 <a:ea typeface="Be Vietnam Pro" pitchFamily="34" charset="-122"/>
                 <a:cs typeface="Be Vietnam Pro" pitchFamily="34" charset="-120"/>
               </a:rPr>
-              <a:t> của</a:t>
-            </a:r>
-            <a:r>
-              <a:rPr lang="en-US" sz="2250" dirty="0" spc="5" kern="0">
+              <a:t> người</a:t>
+            </a:r>
+            <a:r>
+              <a:rPr lang="en-US" sz="2550" dirty="0" spc="-1" kern="0">
                 <a:solidFill>
                   <a:srgbClr val="F3EEE3"/>
                 </a:solidFill>
@@ -3787,20 +3787,9 @@
                 <a:ea typeface="Be Vietnam Pro" pitchFamily="34" charset="-122"/>
                 <a:cs typeface="Be Vietnam Pro" pitchFamily="34" charset="-120"/>
               </a:rPr>
-              <a:t> người</a:t>
-            </a:r>
-            <a:r>
-              <a:rPr lang="en-US" sz="2250" dirty="0" spc="3" kern="0">
-                <a:solidFill>
-                  <a:srgbClr val="F3EEE3"/>
-                </a:solidFill>
-                <a:latin typeface="Be Vietnam Pro" pitchFamily="34" charset="0"/>
-                <a:ea typeface="Be Vietnam Pro" pitchFamily="34" charset="-122"/>
-                <a:cs typeface="Be Vietnam Pro" pitchFamily="34" charset="-120"/>
-              </a:rPr>
               <a:t> dùng</a:t>
             </a:r>
-            <a:endParaRPr lang="en-US" sz="2250" dirty="0"/>
+            <a:endParaRPr lang="en-US" sz="2550" dirty="0"/>
           </a:p>
         </p:txBody>
       </p:sp>
@@ -5216,7 +5205,7 @@
               <a:buNone/>
             </a:pPr>
             <a:r>
-              <a:rPr lang="en-US" sz="2400" dirty="0" spc="-2" kern="0">
+              <a:rPr lang="en-US" sz="2550" dirty="0" spc="1" kern="0">
                 <a:solidFill>
                   <a:srgbClr val="6B6A66"/>
                 </a:solidFill>
@@ -5227,7 +5216,7 @@
               <a:t>Nối</a:t>
             </a:r>
             <a:r>
-              <a:rPr lang="en-US" sz="2400" dirty="0" spc="-22" kern="0">
+              <a:rPr lang="en-US" sz="2550" dirty="0" spc="-21" kern="0">
                 <a:solidFill>
                   <a:srgbClr val="6B6A66"/>
                 </a:solidFill>
@@ -5238,7 +5227,7 @@
               <a:t> yêu</a:t>
             </a:r>
             <a:r>
-              <a:rPr lang="en-US" sz="2400" dirty="0" spc="0" kern="0">
+              <a:rPr lang="en-US" sz="2550" dirty="0" spc="1" kern="0">
                 <a:solidFill>
                   <a:srgbClr val="6B6A66"/>
                 </a:solidFill>
@@ -5249,7 +5238,7 @@
               <a:t> cầu,</a:t>
             </a:r>
             <a:r>
-              <a:rPr lang="en-US" sz="2400" dirty="0" spc="-1" kern="0">
+              <a:rPr lang="en-US" sz="2550" dirty="0" spc="-2" kern="0">
                 <a:solidFill>
                   <a:srgbClr val="6B6A66"/>
                 </a:solidFill>
@@ -5260,7 +5249,7 @@
               <a:t> code,</a:t>
             </a:r>
             <a:r>
-              <a:rPr lang="en-US" sz="2400" dirty="0" spc="-6" kern="0">
+              <a:rPr lang="en-US" sz="2550" dirty="0" spc="-8" kern="0">
                 <a:solidFill>
                   <a:srgbClr val="6B6A66"/>
                 </a:solidFill>
@@ -5271,7 +5260,7 @@
               <a:t> artifact,</a:t>
             </a:r>
             <a:r>
-              <a:rPr lang="en-US" sz="2400" dirty="0" spc="2" kern="0">
+              <a:rPr lang="en-US" sz="2550" dirty="0" spc="1" kern="0">
                 <a:solidFill>
                   <a:srgbClr val="6B6A66"/>
                 </a:solidFill>
@@ -5282,7 +5271,7 @@
               <a:t> môi</a:t>
             </a:r>
             <a:r>
-              <a:rPr lang="en-US" sz="2400" dirty="0" spc="6" kern="0">
+              <a:rPr lang="en-US" sz="2550" dirty="0" spc="5" kern="0">
                 <a:solidFill>
                   <a:srgbClr val="6B6A66"/>
                 </a:solidFill>
@@ -5293,7 +5282,7 @@
               <a:t> trường</a:t>
             </a:r>
             <a:r>
-              <a:rPr lang="en-US" sz="2400" dirty="0" spc="-14" kern="0">
+              <a:rPr lang="en-US" sz="2550" dirty="0" spc="-19" kern="0">
                 <a:solidFill>
                   <a:srgbClr val="6B6A66"/>
                 </a:solidFill>
@@ -5304,7 +5293,7 @@
               <a:t> và</a:t>
             </a:r>
             <a:r>
-              <a:rPr lang="en-US" sz="2400" dirty="0" spc="0" kern="0">
+              <a:rPr lang="en-US" sz="2550" dirty="0" spc="1" kern="0">
                 <a:solidFill>
                   <a:srgbClr val="6B6A66"/>
                 </a:solidFill>
@@ -5315,7 +5304,7 @@
               <a:t> quan</a:t>
             </a:r>
             <a:r>
-              <a:rPr lang="en-US" sz="2400" dirty="0" spc="-14" kern="0">
+              <a:rPr lang="en-US" sz="2550" dirty="0" spc="-15" kern="0">
                 <a:solidFill>
                   <a:srgbClr val="6B6A66"/>
                 </a:solidFill>
@@ -5325,7 +5314,7 @@
               </a:rPr>
               <a:t> sát.</a:t>
             </a:r>
-            <a:endParaRPr lang="en-US" sz="2400" dirty="0"/>
+            <a:endParaRPr lang="en-US" sz="2550" dirty="0"/>
           </a:p>
         </p:txBody>
       </p:sp>
@@ -9524,7 +9513,7 @@
               <a:buNone/>
             </a:pPr>
             <a:r>
-              <a:rPr lang="en-US" sz="2400" dirty="0" spc="-25" kern="0">
+              <a:rPr lang="en-US" sz="2550" dirty="0" spc="-27" kern="0">
                 <a:solidFill>
                   <a:srgbClr val="6B6A66"/>
                 </a:solidFill>
@@ -9535,7 +9524,7 @@
               <a:t>Triển</a:t>
             </a:r>
             <a:r>
-              <a:rPr lang="en-US" sz="2400" dirty="0" spc="-1" kern="0">
+              <a:rPr lang="en-US" sz="2550" dirty="0" spc="0" kern="0">
                 <a:solidFill>
                   <a:srgbClr val="6B6A66"/>
                 </a:solidFill>
@@ -9543,10 +9532,10 @@
                 <a:ea typeface="Be Vietnam Pro" pitchFamily="34" charset="-122"/>
                 <a:cs typeface="Be Vietnam Pro" pitchFamily="34" charset="-120"/>
               </a:rPr>
-              <a:t> khai theo</a:t>
-            </a:r>
-            <a:r>
-              <a:rPr lang="en-US" sz="2400" dirty="0" spc="12" kern="0">
+              <a:t> khai</a:t>
+            </a:r>
+            <a:r>
+              <a:rPr lang="en-US" sz="2550" dirty="0" spc="-2" kern="0">
                 <a:solidFill>
                   <a:srgbClr val="6B6A66"/>
                 </a:solidFill>
@@ -9554,10 +9543,21 @@
                 <a:ea typeface="Be Vietnam Pro" pitchFamily="34" charset="-122"/>
                 <a:cs typeface="Be Vietnam Pro" pitchFamily="34" charset="-120"/>
               </a:rPr>
+              <a:t> theo</a:t>
+            </a:r>
+            <a:r>
+              <a:rPr lang="en-US" sz="2550" dirty="0" spc="11" kern="0">
+                <a:solidFill>
+                  <a:srgbClr val="6B6A66"/>
+                </a:solidFill>
+                <a:latin typeface="Be Vietnam Pro" pitchFamily="34" charset="0"/>
+                <a:ea typeface="Be Vietnam Pro" pitchFamily="34" charset="-122"/>
+                <a:cs typeface="Be Vietnam Pro" pitchFamily="34" charset="-120"/>
+              </a:rPr>
               <a:t> đợt,</a:t>
             </a:r>
             <a:r>
-              <a:rPr lang="en-US" sz="2400" dirty="0" spc="1" kern="0">
+              <a:rPr lang="en-US" sz="2550" dirty="0" spc="-1" kern="0">
                 <a:solidFill>
                   <a:srgbClr val="6B6A66"/>
                 </a:solidFill>
@@ -9568,7 +9568,7 @@
               <a:t> canary</a:t>
             </a:r>
             <a:r>
-              <a:rPr lang="en-US" sz="2400" dirty="0" spc="-1" kern="0">
+              <a:rPr lang="en-US" sz="2550" dirty="0" spc="-2" kern="0">
                 <a:solidFill>
                   <a:srgbClr val="6B6A66"/>
                 </a:solidFill>
@@ -9576,10 +9576,10 @@
                 <a:ea typeface="Be Vietnam Pro" pitchFamily="34" charset="-122"/>
                 <a:cs typeface="Be Vietnam Pro" pitchFamily="34" charset="-120"/>
               </a:rPr>
-              <a:t> hoặc lịch.</a:t>
-            </a:r>
-            <a:r>
-              <a:rPr lang="en-US" sz="2400" dirty="0" spc="-2" kern="0">
+              <a:t> hoặc</a:t>
+            </a:r>
+            <a:r>
+              <a:rPr lang="en-US" sz="2550" dirty="0" spc="1" kern="0">
                 <a:solidFill>
                   <a:srgbClr val="6B6A66"/>
                 </a:solidFill>
@@ -9587,10 +9587,21 @@
                 <a:ea typeface="Be Vietnam Pro" pitchFamily="34" charset="-122"/>
                 <a:cs typeface="Be Vietnam Pro" pitchFamily="34" charset="-120"/>
               </a:rPr>
+              <a:t> lịch.</a:t>
+            </a:r>
+            <a:r>
+              <a:rPr lang="en-US" sz="2550" dirty="0" spc="-3" kern="0">
+                <a:solidFill>
+                  <a:srgbClr val="6B6A66"/>
+                </a:solidFill>
+                <a:latin typeface="Be Vietnam Pro" pitchFamily="34" charset="0"/>
+                <a:ea typeface="Be Vietnam Pro" pitchFamily="34" charset="-122"/>
+                <a:cs typeface="Be Vietnam Pro" pitchFamily="34" charset="-120"/>
+              </a:rPr>
               <a:t> Theo</a:t>
             </a:r>
             <a:r>
-              <a:rPr lang="en-US" sz="2400" dirty="0" spc="0" kern="0">
+              <a:rPr lang="en-US" sz="2550" dirty="0" spc="0" kern="0">
                 <a:solidFill>
                   <a:srgbClr val="6B6A66"/>
                 </a:solidFill>
@@ -9600,7 +9611,7 @@
               </a:rPr>
               <a:t> dõi:</a:t>
             </a:r>
-            <a:endParaRPr lang="en-US" sz="2400" dirty="0"/>
+            <a:endParaRPr lang="en-US" sz="2550" dirty="0"/>
           </a:p>
         </p:txBody>
       </p:sp>
@@ -10242,7 +10253,7 @@
               <a:buNone/>
             </a:pPr>
             <a:r>
-              <a:rPr lang="en-US" sz="2400" dirty="0" spc="-1" kern="0">
+              <a:rPr lang="en-US" sz="2550" dirty="0" spc="-1" kern="0">
                 <a:solidFill>
                   <a:srgbClr val="6B6A66"/>
                 </a:solidFill>
@@ -10250,10 +10261,10 @@
                 <a:ea typeface="Be Vietnam Pro" pitchFamily="34" charset="-122"/>
                 <a:cs typeface="Be Vietnam Pro" pitchFamily="34" charset="-120"/>
               </a:rPr>
-              <a:t>Tín hiệu</a:t>
-            </a:r>
-            <a:r>
-              <a:rPr lang="en-US" sz="2400" dirty="0" spc="-12" kern="0">
+              <a:t>Tín</a:t>
+            </a:r>
+            <a:r>
+              <a:rPr lang="en-US" sz="2550" dirty="0" spc="1" kern="0">
                 <a:solidFill>
                   <a:srgbClr val="6B6A66"/>
                 </a:solidFill>
@@ -10261,10 +10272,21 @@
                 <a:ea typeface="Be Vietnam Pro" pitchFamily="34" charset="-122"/>
                 <a:cs typeface="Be Vietnam Pro" pitchFamily="34" charset="-120"/>
               </a:rPr>
+              <a:t> hiệu</a:t>
+            </a:r>
+            <a:r>
+              <a:rPr lang="en-US" sz="2550" dirty="0" spc="-14" kern="0">
+                <a:solidFill>
+                  <a:srgbClr val="6B6A66"/>
+                </a:solidFill>
+                <a:latin typeface="Be Vietnam Pro" pitchFamily="34" charset="0"/>
+                <a:ea typeface="Be Vietnam Pro" pitchFamily="34" charset="-122"/>
+                <a:cs typeface="Be Vietnam Pro" pitchFamily="34" charset="-120"/>
+              </a:rPr>
               <a:t> vận</a:t>
             </a:r>
             <a:r>
-              <a:rPr lang="en-US" sz="2400" dirty="0" spc="1" kern="0">
+              <a:rPr lang="en-US" sz="2550" dirty="0" spc="0" kern="0">
                 <a:solidFill>
                   <a:srgbClr val="6B6A66"/>
                 </a:solidFill>
@@ -10275,7 +10297,7 @@
               <a:t> hành</a:t>
             </a:r>
             <a:r>
-              <a:rPr lang="en-US" sz="2400" dirty="0" spc="-7" kern="0">
+              <a:rPr lang="en-US" sz="2550" dirty="0" spc="-7" kern="0">
                 <a:solidFill>
                   <a:srgbClr val="6B6A66"/>
                 </a:solidFill>
@@ -10286,7 +10308,7 @@
               <a:t> quay</a:t>
             </a:r>
             <a:r>
-              <a:rPr lang="en-US" sz="2400" dirty="0" spc="-17" kern="0">
+              <a:rPr lang="en-US" sz="2550" dirty="0" spc="-19" kern="0">
                 <a:solidFill>
                   <a:srgbClr val="6B6A66"/>
                 </a:solidFill>
@@ -10297,7 +10319,7 @@
               <a:t> về</a:t>
             </a:r>
             <a:r>
-              <a:rPr lang="en-US" sz="2400" dirty="0" spc="-22" kern="0">
+              <a:rPr lang="en-US" sz="2550" dirty="0" spc="-20" kern="0">
                 <a:solidFill>
                   <a:srgbClr val="6B6A66"/>
                 </a:solidFill>
@@ -10308,7 +10330,7 @@
               <a:t> yêu</a:t>
             </a:r>
             <a:r>
-              <a:rPr lang="en-US" sz="2400" dirty="0" spc="0" kern="0">
+              <a:rPr lang="en-US" sz="2550" dirty="0" spc="1" kern="0">
                 <a:solidFill>
                   <a:srgbClr val="6B6A66"/>
                 </a:solidFill>
@@ -10319,7 +10341,7 @@
               <a:t> cầu,</a:t>
             </a:r>
             <a:r>
-              <a:rPr lang="en-US" sz="2400" dirty="0" spc="-12" kern="0">
+              <a:rPr lang="en-US" sz="2550" dirty="0" spc="-11" kern="0">
                 <a:solidFill>
                   <a:srgbClr val="6B6A66"/>
                 </a:solidFill>
@@ -10329,7 +10351,7 @@
               </a:rPr>
               <a:t> test.</a:t>
             </a:r>
-            <a:endParaRPr lang="en-US" sz="2400" dirty="0"/>
+            <a:endParaRPr lang="en-US" sz="2550" dirty="0"/>
           </a:p>
         </p:txBody>
       </p:sp>

</xml_diff>